<commit_message>
Final fix: Align QR generator and pages numbering, verified safe with triple quotes
</commit_message>
<xml_diff>
--- a/QR_Esperimenti_Bias_FINALE.pptx
+++ b/QR_Esperimenti_Bias_FINALE.pptx
@@ -3147,7 +3147,7 @@
           <a:lstStyle/>
           <a:p>
             <a:r>
-              <a:t>Tutti i 21 Esperimenti Kahneman</a:t>
+              <a:t>Tutti i 22 Esperimenti Kahneman</a:t>
             </a:r>
           </a:p>
           <a:p>
@@ -4489,7 +4489,7 @@
           <a:lstStyle/>
           <a:p>
             <a:r>
-              <a:t>19. Base Rate Neglect</a:t>
+              <a:t>19. Illusione di Focalizzazione (Felicità)</a:t>
             </a:r>
           </a:p>
         </p:txBody>
@@ -4513,7 +4513,7 @@
       </p:sp>
       <p:pic>
         <p:nvPicPr>
-          <p:cNvPr id="4" name="Picture 3" descr="Base_Rate_Neglect.png"/>
+          <p:cNvPr id="4" name="Picture 3" descr="Illusione_Focalizzazione.png"/>
           <p:cNvPicPr>
             <a:picLocks noChangeAspect="1"/>
           </p:cNvPicPr>
@@ -4607,7 +4607,7 @@
           <a:lstStyle/>
           <a:p>
             <a:r>
-              <a:t>20. Decoy Effect (L'Esca)</a:t>
+              <a:t>20. Base Rate Neglect</a:t>
             </a:r>
           </a:p>
         </p:txBody>
@@ -4631,7 +4631,7 @@
       </p:sp>
       <p:pic>
         <p:nvPicPr>
-          <p:cNvPr id="4" name="Picture 3" descr="L_Esca.png"/>
+          <p:cNvPr id="4" name="Picture 3" descr="Base_Rate_Neglect.png"/>
           <p:cNvPicPr>
             <a:picLocks noChangeAspect="1"/>
           </p:cNvPicPr>
@@ -4725,7 +4725,7 @@
           <a:lstStyle/>
           <a:p>
             <a:r>
-              <a:t>21. Regressione alla Media</a:t>
+              <a:t>21. Decoy Effect (L'Esca)</a:t>
             </a:r>
           </a:p>
         </p:txBody>
@@ -4749,7 +4749,7 @@
       </p:sp>
       <p:pic>
         <p:nvPicPr>
-          <p:cNvPr id="4" name="Picture 3" descr="Regressione_Media.png"/>
+          <p:cNvPr id="4" name="Picture 3" descr="L_Esca.png"/>
           <p:cNvPicPr>
             <a:picLocks noChangeAspect="1"/>
           </p:cNvPicPr>
@@ -4843,7 +4843,7 @@
           <a:lstStyle/>
           <a:p>
             <a:r>
-              <a:t>22. Illusione di Focalizzazione (Felicità)</a:t>
+              <a:t>22. Regressione alla Media</a:t>
             </a:r>
           </a:p>
         </p:txBody>
@@ -4867,7 +4867,7 @@
       </p:sp>
       <p:pic>
         <p:nvPicPr>
-          <p:cNvPr id="4" name="Picture 3" descr="Illusione_Focalizzazione.png"/>
+          <p:cNvPr id="4" name="Picture 3" descr="Regressione_Media.png"/>
           <p:cNvPicPr>
             <a:picLocks noChangeAspect="1"/>
           </p:cNvPicPr>

</xml_diff>